<commit_message>
Added first draft of the <Related Work> Section to my ba thesis presentation.
</commit_message>
<xml_diff>
--- a/dev_documents/presentation/presentation_template_unibern.pptx
+++ b/dev_documents/presentation/presentation_template_unibern.pptx
@@ -206,7 +206,7 @@
           <a:p>
             <a:fld id="{442B13D9-EE20-4263-A517-453A6CC03581}" type="datetimeFigureOut">
               <a:rPr lang="en-US" smtClean="0"/>
-              <a:t>1/31/2026</a:t>
+              <a:t>2/1/2026</a:t>
             </a:fld>
             <a:endParaRPr lang="en-US"/>
           </a:p>
@@ -371,7 +371,7 @@
           <a:p>
             <a:fld id="{C4B9E2E8-0589-406D-8FD1-7B0DBC84FBDE}" type="datetimeFigureOut">
               <a:rPr lang="de-CH" smtClean="0"/>
-              <a:t>31.01.2026</a:t>
+              <a:t>01.02.2026</a:t>
             </a:fld>
             <a:endParaRPr lang="de-CH"/>
           </a:p>
@@ -31421,7 +31421,7 @@
           <a:bodyPr/>
           <a:lstStyle/>
           <a:p>
-            <a:endParaRPr lang="en-US"/>
+            <a:endParaRPr lang="en-US" dirty="0"/>
           </a:p>
         </p:txBody>
       </p:sp>
@@ -31440,7 +31440,7 @@
           <a:bodyPr/>
           <a:lstStyle/>
           <a:p>
-            <a:endParaRPr lang="en-US"/>
+            <a:endParaRPr lang="en-US" dirty="0"/>
           </a:p>
         </p:txBody>
       </p:sp>
@@ -31459,7 +31459,7 @@
           <a:bodyPr/>
           <a:lstStyle/>
           <a:p>
-            <a:endParaRPr lang="en-US"/>
+            <a:endParaRPr lang="en-US" dirty="0"/>
           </a:p>
         </p:txBody>
       </p:sp>

</xml_diff>